<commit_message>
Correct BVP/Genuine takeaway on the GPS deep-dive slide
The original bullet called the BVP/Genuine mix "stable, not a driver" based
on the ratio staying in a 12-18% band through 2024. That undersold the
2025 break: YoY, Genuine fell EUR 71K while BVP grew EUR 4K — the whole
post-peak decline is concentrated in Genuine parts specifically, not a
mix-shift artifact. Updated the takeaway and the matching question on the
competitive-capture slide.
</commit_message>
<xml_diff>
--- a/09_meetings/HUNGARY_Sales_Review_2026/ISZE_HUNGARY_Sales_Review_FY2027.pptx
+++ b/09_meetings/HUNGARY_Sales_Review_2026/ISZE_HUNGARY_Sales_Review_FY2027.pptx
@@ -11105,7 +11105,7 @@
                 </a:solidFill>
                 <a:latin typeface="Calibri"/>
               </a:rPr>
-              <a:t>Genuine parts have held 82-88% of billing every year since 2020 (BVP 12-18%) — a stable mix, so it isn't what moved GPS.</a:t>
+              <a:t>BVP held 12-18% share through 2024, but 2025's decline is entirely Genuine (-EUR 71K) while BVP grew (+EUR 4K) — a Genuine-parts problem, not a BVP one.</a:t>
             </a:r>
           </a:p>
           <a:p>
@@ -11161,7 +11161,7 @@
                 </a:solidFill>
                 <a:latin typeface="Calibri"/>
               </a:rPr>
-              <a:t>The FY2027 base is disputed: corrected-survival shows the parc shrinking to 3,645 (-2.4%); UIO V19 shows it growing to 3,992 (+6.9%). Worth agreeing which one we plan against.</a:t>
+              <a:t>The FY2027 base is disputed: corrected-survival shrinks the parc to 3,645 (-2.4%); UIO V19 grows it to 3,992 (+6.9%) — worth agreeing which.</a:t>
             </a:r>
           </a:p>
         </p:txBody>
@@ -12382,7 +12382,7 @@
                 </a:solidFill>
                 <a:latin typeface="Calibri"/>
               </a:rPr>
-              <a:t>BVP has held 13-18% of billing since 2020 — right mix, or room to push further into price-sensitive segments?</a:t>
+              <a:t>Genuine parts fell EUR 71K in 2025 while BVP grew EUR 4K — is genuine business moving to the aftermarket, or are dealers trading down within our own catalog?</a:t>
             </a:r>
           </a:p>
         </p:txBody>

</xml_diff>

<commit_message>
Add dedicated Genuine vs BVP deep-dive slide; correct warranty-source caveat
New slide 20: full year-by-year Genuine vs BVP billing (2020-2025), not just
a summary bullet. 2025 is the only year the two move in opposite directions
(Genuine -EUR 71K, BVP +EUR 4K) -- confirmed across revenue, unit volume
(9,216 -> 7,372) and SKU breadth (1,160 -> 930 distinct genuine part
numbers), so it isn't a pricing artifact.

Also verified the warranty-claims figure quoted on the competitive-capture
slide is NOT derived from the sales billing extract (no SaTy/warranty flag,
no zero-value F2 lines, no warranty text in descriptions -- checked all
three) -- it comes from the separate warranty-claims canonical file. Slide
wording now says so explicitly instead of implying it's part of the same
billing analysis.
</commit_message>
<xml_diff>
--- a/09_meetings/HUNGARY_Sales_Review_2026/ISZE_HUNGARY_Sales_Review_FY2027.pptx
+++ b/09_meetings/HUNGARY_Sales_Review_2026/ISZE_HUNGARY_Sales_Review_FY2027.pptx
@@ -25,6 +25,7 @@
     <p:sldId id="273" r:id="rId24"/>
     <p:sldId id="275" r:id="rId26"/>
     <p:sldId id="276" r:id="rId27"/>
+    <p:sldId id="277" r:id="rId28"/>
     <p:sldId id="274" r:id="rId25"/>
   </p:sldIdLst>
   <p:sldSz cx="12188952" cy="6858000" type="screen4x3"/>
@@ -11289,7 +11290,7 @@
                 </a:solidFill>
                 <a:latin typeface="Calibri"/>
               </a:rPr>
-              <a:t>DEEP DIVE — COMPETITIVE CAPTURE</a:t>
+              <a:t>DEEP DIVE — GENUINE VS BVP</a:t>
             </a:r>
           </a:p>
         </p:txBody>
@@ -11324,7 +11325,7 @@
                 </a:solidFill>
                 <a:latin typeface="Calibri"/>
               </a:rPr>
-              <a:t>Where the gap is: competitive parts leaking to the aftermarket</a:t>
+              <a:t>Genuine vs BVP: 2025 breaks the pattern</a:t>
             </a:r>
           </a:p>
         </p:txBody>
@@ -11403,6 +11404,484 @@
                 <a:latin typeface="Calibri"/>
               </a:rPr>
               <a:t>20</a:t>
+            </a:r>
+          </a:p>
+        </p:txBody>
+      </p:sp>
+      <p:pic>
+        <p:nvPicPr>
+          <p:cNvPr id="8" name="Picture 7" descr="bvp_genuine.png"/>
+          <p:cNvPicPr>
+            <a:picLocks noChangeAspect="1"/>
+          </p:cNvPicPr>
+          <p:nvPr/>
+        </p:nvPicPr>
+        <p:blipFill>
+          <a:blip r:embed="rId3"/>
+          <a:stretch>
+            <a:fillRect/>
+          </a:stretch>
+        </p:blipFill>
+        <p:spPr>
+          <a:xfrm>
+            <a:off x="292608" y="2121722"/>
+            <a:ext cx="7178040" cy="3026036"/>
+          </a:xfrm>
+          <a:prstGeom prst="rect">
+            <a:avLst/>
+          </a:prstGeom>
+        </p:spPr>
+      </p:pic>
+      <p:sp>
+        <p:nvSpPr>
+          <p:cNvPr id="9" name="Rectangle 8"/>
+          <p:cNvSpPr/>
+          <p:nvPr/>
+        </p:nvSpPr>
+        <p:spPr>
+          <a:xfrm>
+            <a:off x="7726679" y="1188720"/>
+            <a:ext cx="22000" cy="4892040"/>
+          </a:xfrm>
+          <a:prstGeom prst="rect">
+            <a:avLst/>
+          </a:prstGeom>
+          <a:solidFill>
+            <a:srgbClr val="ECECEC"/>
+          </a:solidFill>
+          <a:ln>
+            <a:noFill/>
+          </a:ln>
+        </p:spPr>
+        <p:style>
+          <a:lnRef idx="1">
+            <a:schemeClr val="accent1"/>
+          </a:lnRef>
+          <a:fillRef idx="3">
+            <a:schemeClr val="accent1"/>
+          </a:fillRef>
+          <a:effectRef idx="2">
+            <a:schemeClr val="accent1"/>
+          </a:effectRef>
+          <a:fontRef idx="minor">
+            <a:schemeClr val="lt1"/>
+          </a:fontRef>
+        </p:style>
+        <p:txBody>
+          <a:bodyPr rtlCol="0" anchor="ctr"/>
+          <a:lstStyle/>
+          <a:p>
+            <a:pPr algn="ctr"/>
+          </a:p>
+        </p:txBody>
+      </p:sp>
+      <p:sp>
+        <p:nvSpPr>
+          <p:cNvPr id="10" name="TextBox 9"/>
+          <p:cNvSpPr txBox="1"/>
+          <p:nvPr/>
+        </p:nvSpPr>
+        <p:spPr>
+          <a:xfrm>
+            <a:off x="7927847" y="1234440"/>
+            <a:ext cx="3886200" cy="320040"/>
+          </a:xfrm>
+          <a:prstGeom prst="rect">
+            <a:avLst/>
+          </a:prstGeom>
+          <a:noFill/>
+        </p:spPr>
+        <p:txBody>
+          <a:bodyPr wrap="square">
+            <a:spAutoFit/>
+          </a:bodyPr>
+          <a:lstStyle/>
+          <a:p>
+            <a:pPr algn="l"/>
+            <a:r>
+              <a:rPr sz="1200" b="1">
+                <a:solidFill>
+                  <a:srgbClr val="CC0E1E"/>
+                </a:solidFill>
+                <a:latin typeface="Calibri"/>
+              </a:rPr>
+              <a:t>TAKEAWAYS</a:t>
+            </a:r>
+          </a:p>
+        </p:txBody>
+      </p:sp>
+      <p:sp>
+        <p:nvSpPr>
+          <p:cNvPr id="11" name="TextBox 10"/>
+          <p:cNvSpPr txBox="1"/>
+          <p:nvPr/>
+        </p:nvSpPr>
+        <p:spPr>
+          <a:xfrm>
+            <a:off x="7927847" y="1691640"/>
+            <a:ext cx="3794760" cy="4343400"/>
+          </a:xfrm>
+          <a:prstGeom prst="rect">
+            <a:avLst/>
+          </a:prstGeom>
+          <a:noFill/>
+        </p:spPr>
+        <p:txBody>
+          <a:bodyPr wrap="square">
+            <a:spAutoFit/>
+          </a:bodyPr>
+          <a:lstStyle/>
+          <a:p>
+            <a:pPr>
+              <a:lnSpc>
+                <a:spcPct val="125000"/>
+              </a:lnSpc>
+              <a:spcAft>
+                <a:spcPts val="1000"/>
+              </a:spcAft>
+            </a:pPr>
+            <a:r>
+              <a:rPr sz="1250" b="1">
+                <a:solidFill>
+                  <a:srgbClr val="CC0E1E"/>
+                </a:solidFill>
+                <a:latin typeface="Calibri"/>
+              </a:rPr>
+              <a:t>—  </a:t>
+            </a:r>
+            <a:r>
+              <a:rPr sz="1250">
+                <a:solidFill>
+                  <a:srgbClr val="1A1A1A"/>
+                </a:solidFill>
+                <a:latin typeface="Calibri"/>
+              </a:rPr>
+              <a:t>2025 is the only year since 2020 where Genuine and BVP move in opposite directions: Genuine EUR 341K → EUR 270K (-71K); BVP EUR 48K → EUR 52K (+4K). Every prior year they moved together.</a:t>
+            </a:r>
+          </a:p>
+          <a:p>
+            <a:pPr>
+              <a:lnSpc>
+                <a:spcPct val="125000"/>
+              </a:lnSpc>
+              <a:spcAft>
+                <a:spcPts val="1000"/>
+              </a:spcAft>
+            </a:pPr>
+            <a:r>
+              <a:rPr sz="1250" b="1">
+                <a:solidFill>
+                  <a:srgbClr val="CC0E1E"/>
+                </a:solidFill>
+                <a:latin typeface="Calibri"/>
+              </a:rPr>
+              <a:t>—  </a:t>
+            </a:r>
+            <a:r>
+              <a:rPr sz="1250">
+                <a:solidFill>
+                  <a:srgbClr val="1A1A1A"/>
+                </a:solidFill>
+                <a:latin typeface="Calibri"/>
+              </a:rPr>
+              <a:t>Not just a pricing effect: Genuine volume also fell (9,216 → 7,372 units) and breadth contracted (1,160 → 930 distinct genuine part numbers sold, -20%).</a:t>
+            </a:r>
+          </a:p>
+          <a:p>
+            <a:pPr>
+              <a:lnSpc>
+                <a:spcPct val="125000"/>
+              </a:lnSpc>
+              <a:spcAft>
+                <a:spcPts val="1000"/>
+              </a:spcAft>
+            </a:pPr>
+            <a:r>
+              <a:rPr sz="1250" b="1">
+                <a:solidFill>
+                  <a:srgbClr val="CC0E1E"/>
+                </a:solidFill>
+                <a:latin typeface="Calibri"/>
+              </a:rPr>
+              <a:t>—  </a:t>
+            </a:r>
+            <a:r>
+              <a:rPr sz="1250">
+                <a:solidFill>
+                  <a:srgbClr val="1A1A1A"/>
+                </a:solidFill>
+                <a:latin typeface="Calibri"/>
+              </a:rPr>
+              <a:t>BVP held up on every measure over the same year — units flat (4,036 → 4,052), SKU breadth grew (37 → 43) — so this isn't distributor-wide destocking, it's specific to Genuine.</a:t>
+            </a:r>
+          </a:p>
+          <a:p>
+            <a:pPr>
+              <a:lnSpc>
+                <a:spcPct val="125000"/>
+              </a:lnSpc>
+              <a:spcAft>
+                <a:spcPts val="1000"/>
+              </a:spcAft>
+            </a:pPr>
+            <a:r>
+              <a:rPr sz="1250" b="1">
+                <a:solidFill>
+                  <a:srgbClr val="CC0E1E"/>
+                </a:solidFill>
+                <a:latin typeface="Calibri"/>
+              </a:rPr>
+              <a:t>—  </a:t>
+            </a:r>
+            <a:r>
+              <a:rPr sz="1250">
+                <a:solidFill>
+                  <a:srgbClr val="1A1A1A"/>
+                </a:solidFill>
+                <a:latin typeface="Calibri"/>
+              </a:rPr>
+              <a:t>Worth cutting the 2025 genuine drop by category together before assuming it's competitive leakage — a concentrated cause (e.g. one model, one dealer) reads very differently from a broad-based one.</a:t>
+            </a:r>
+          </a:p>
+        </p:txBody>
+      </p:sp>
+    </p:spTree>
+  </p:cSld>
+  <p:clrMapOvr>
+    <a:masterClrMapping/>
+  </p:clrMapOvr>
+</p:sld>
+</file>
+
+<file path=ppt/slides/slide22.xml><?xml version="1.0" encoding="utf-8"?>
+<p:sld xmlns:a="http://schemas.openxmlformats.org/drawingml/2006/main" xmlns:p="http://schemas.openxmlformats.org/presentationml/2006/main" xmlns:r="http://schemas.openxmlformats.org/officeDocument/2006/relationships">
+  <p:cSld>
+    <p:bg>
+      <p:bgPr>
+        <a:solidFill>
+          <a:srgbClr val="FFFFFF"/>
+        </a:solidFill>
+        <a:effectLst/>
+      </p:bgPr>
+    </p:bg>
+    <p:spTree>
+      <p:nvGrpSpPr>
+        <p:cNvPr id="1" name=""/>
+        <p:cNvGrpSpPr/>
+        <p:nvPr/>
+      </p:nvGrpSpPr>
+      <p:grpSpPr/>
+      <p:pic>
+        <p:nvPicPr>
+          <p:cNvPr id="2" name="Picture 1" descr="image.png"/>
+          <p:cNvPicPr>
+            <a:picLocks noChangeAspect="1"/>
+          </p:cNvPicPr>
+          <p:nvPr/>
+        </p:nvPicPr>
+        <p:blipFill>
+          <a:blip r:embed="rId2"/>
+          <a:stretch>
+            <a:fillRect/>
+          </a:stretch>
+        </p:blipFill>
+        <p:spPr>
+          <a:xfrm>
+            <a:off x="256032" y="6263640"/>
+            <a:ext cx="1679787" cy="292608"/>
+          </a:xfrm>
+          <a:prstGeom prst="rect">
+            <a:avLst/>
+          </a:prstGeom>
+        </p:spPr>
+      </p:pic>
+      <p:sp>
+        <p:nvSpPr>
+          <p:cNvPr id="3" name="Rectangle 2"/>
+          <p:cNvSpPr/>
+          <p:nvPr/>
+        </p:nvSpPr>
+        <p:spPr>
+          <a:xfrm>
+            <a:off x="0" y="6766560"/>
+            <a:ext cx="12188952" cy="91440"/>
+          </a:xfrm>
+          <a:prstGeom prst="rect">
+            <a:avLst/>
+          </a:prstGeom>
+          <a:solidFill>
+            <a:srgbClr val="CC0E1E"/>
+          </a:solidFill>
+          <a:ln>
+            <a:noFill/>
+          </a:ln>
+        </p:spPr>
+        <p:style>
+          <a:lnRef idx="1">
+            <a:schemeClr val="accent1"/>
+          </a:lnRef>
+          <a:fillRef idx="3">
+            <a:schemeClr val="accent1"/>
+          </a:fillRef>
+          <a:effectRef idx="2">
+            <a:schemeClr val="accent1"/>
+          </a:effectRef>
+          <a:fontRef idx="minor">
+            <a:schemeClr val="lt1"/>
+          </a:fontRef>
+        </p:style>
+        <p:txBody>
+          <a:bodyPr rtlCol="0" anchor="ctr"/>
+          <a:lstStyle/>
+          <a:p>
+            <a:pPr algn="ctr"/>
+          </a:p>
+        </p:txBody>
+      </p:sp>
+      <p:sp>
+        <p:nvSpPr>
+          <p:cNvPr id="4" name="TextBox 3"/>
+          <p:cNvSpPr txBox="1"/>
+          <p:nvPr/>
+        </p:nvSpPr>
+        <p:spPr>
+          <a:xfrm>
+            <a:off x="292608" y="201168"/>
+            <a:ext cx="11430000" cy="274320"/>
+          </a:xfrm>
+          <a:prstGeom prst="rect">
+            <a:avLst/>
+          </a:prstGeom>
+          <a:noFill/>
+        </p:spPr>
+        <p:txBody>
+          <a:bodyPr wrap="square">
+            <a:spAutoFit/>
+          </a:bodyPr>
+          <a:lstStyle/>
+          <a:p>
+            <a:pPr algn="l"/>
+            <a:r>
+              <a:rPr sz="1100" b="1">
+                <a:solidFill>
+                  <a:srgbClr val="CC0E1E"/>
+                </a:solidFill>
+                <a:latin typeface="Calibri"/>
+              </a:rPr>
+              <a:t>DEEP DIVE — COMPETITIVE CAPTURE</a:t>
+            </a:r>
+          </a:p>
+        </p:txBody>
+      </p:sp>
+      <p:sp>
+        <p:nvSpPr>
+          <p:cNvPr id="5" name="TextBox 4"/>
+          <p:cNvSpPr txBox="1"/>
+          <p:nvPr/>
+        </p:nvSpPr>
+        <p:spPr>
+          <a:xfrm>
+            <a:off x="292608" y="475488"/>
+            <a:ext cx="11612880" cy="566928"/>
+          </a:xfrm>
+          <a:prstGeom prst="rect">
+            <a:avLst/>
+          </a:prstGeom>
+          <a:noFill/>
+        </p:spPr>
+        <p:txBody>
+          <a:bodyPr wrap="square">
+            <a:spAutoFit/>
+          </a:bodyPr>
+          <a:lstStyle/>
+          <a:p>
+            <a:pPr algn="l"/>
+            <a:r>
+              <a:rPr sz="2500" b="1">
+                <a:solidFill>
+                  <a:srgbClr val="1A1A1A"/>
+                </a:solidFill>
+                <a:latin typeface="Calibri"/>
+              </a:rPr>
+              <a:t>Where the gap is: competitive parts leaking to the aftermarket</a:t>
+            </a:r>
+          </a:p>
+        </p:txBody>
+      </p:sp>
+      <p:sp>
+        <p:nvSpPr>
+          <p:cNvPr id="6" name="Rectangle 5"/>
+          <p:cNvSpPr/>
+          <p:nvPr/>
+        </p:nvSpPr>
+        <p:spPr>
+          <a:xfrm>
+            <a:off x="292608" y="1005840"/>
+            <a:ext cx="11612880" cy="28000"/>
+          </a:xfrm>
+          <a:prstGeom prst="rect">
+            <a:avLst/>
+          </a:prstGeom>
+          <a:solidFill>
+            <a:srgbClr val="CC0E1E"/>
+          </a:solidFill>
+          <a:ln>
+            <a:noFill/>
+          </a:ln>
+        </p:spPr>
+        <p:style>
+          <a:lnRef idx="1">
+            <a:schemeClr val="accent1"/>
+          </a:lnRef>
+          <a:fillRef idx="3">
+            <a:schemeClr val="accent1"/>
+          </a:fillRef>
+          <a:effectRef idx="2">
+            <a:schemeClr val="accent1"/>
+          </a:effectRef>
+          <a:fontRef idx="minor">
+            <a:schemeClr val="lt1"/>
+          </a:fontRef>
+        </p:style>
+        <p:txBody>
+          <a:bodyPr rtlCol="0" anchor="ctr"/>
+          <a:lstStyle/>
+          <a:p>
+            <a:pPr algn="ctr"/>
+          </a:p>
+        </p:txBody>
+      </p:sp>
+      <p:sp>
+        <p:nvSpPr>
+          <p:cNvPr id="7" name="TextBox 6"/>
+          <p:cNvSpPr txBox="1"/>
+          <p:nvPr/>
+        </p:nvSpPr>
+        <p:spPr>
+          <a:xfrm>
+            <a:off x="11594592" y="6473952"/>
+            <a:ext cx="365760" cy="274320"/>
+          </a:xfrm>
+          <a:prstGeom prst="rect">
+            <a:avLst/>
+          </a:prstGeom>
+          <a:noFill/>
+        </p:spPr>
+        <p:txBody>
+          <a:bodyPr wrap="square">
+            <a:spAutoFit/>
+          </a:bodyPr>
+          <a:lstStyle/>
+          <a:p>
+            <a:pPr algn="r"/>
+            <a:r>
+              <a:rPr sz="1000" b="0">
+                <a:solidFill>
+                  <a:srgbClr val="5A5A5A"/>
+                </a:solidFill>
+                <a:latin typeface="Calibri"/>
+              </a:rPr>
+              <a:t>21</a:t>
             </a:r>
           </a:p>
         </p:txBody>
@@ -12212,7 +12691,7 @@
                 </a:solidFill>
                 <a:latin typeface="Calibri"/>
               </a:rPr>
-              <a:t>Warranty claims jumped from near-zero (FY2024: EUR 225) to EUR 102,418 (FY2026) — right where GPS started easing back. Worth separating a genuine quality trend from a claims-logging change or a campaign.</a:t>
+              <a:t>Warranty claims (separate claims-system data, not part of the billing above) jumped from near-zero (FY2024: EUR 225) to EUR 102,418 (FY2026) — right where GPS started easing back. Worth checking if that's a genuine quality trend, a claims-logging change, or a campaign.</a:t>
             </a:r>
           </a:p>
         </p:txBody>

</xml_diff>

<commit_message>
Prefer FY on sales-review decks; GPS deep dive is two FY lines only.
Drop the calendar-year GPS series from the deep-dive chart, keep fleet Total-only when one segment dominates, and refresh IBX/UMI/Hungary packs.

Co-authored-by: Cursor <cursoragent@cursor.com>
</commit_message>
<xml_diff>
--- a/09_meetings/HUNGARY_Sales_Review_2026/ISZE_HUNGARY_Sales_Review_FY2027.pptx
+++ b/09_meetings/HUNGARY_Sales_Review_2026/ISZE_HUNGARY_Sales_Review_FY2027.pptx
@@ -5686,6 +5686,34 @@
                 </a:solidFill>
                 <a:latin typeface="Calibri"/>
               </a:rPr>
+              <a:t>End-2026 mix: LCV / D-Max 3,645; CV — LD 0.</a:t>
+            </a:r>
+          </a:p>
+          <a:p>
+            <a:pPr>
+              <a:lnSpc>
+                <a:spcPct val="125000"/>
+              </a:lnSpc>
+              <a:spcAft>
+                <a:spcPts val="1000"/>
+              </a:spcAft>
+            </a:pPr>
+            <a:r>
+              <a:rPr sz="1250" b="1">
+                <a:solidFill>
+                  <a:srgbClr val="CC0E1E"/>
+                </a:solidFill>
+                <a:latin typeface="Calibri"/>
+              </a:rPr>
+              <a:t>—  </a:t>
+            </a:r>
+            <a:r>
+              <a:rPr sz="1250">
+                <a:solidFill>
+                  <a:srgbClr val="1A1A1A"/>
+                </a:solidFill>
+                <a:latin typeface="Calibri"/>
+              </a:rPr>
               <a:t>The FY2027 Sales-to-Dealer target starts from that fleet change, then applies a 5% price adjustment and 1.8% additional growth.</a:t>
             </a:r>
           </a:p>
@@ -11768,7 +11796,7 @@
                 </a:solidFill>
                 <a:latin typeface="Calibri"/>
               </a:rPr>
-              <a:t>GPS — calendar year and fiscal year on one chart (incl. warranty)</a:t>
+              <a:t>GPS — fiscal year (headline vs excl. warranty; max two lines)</a:t>
             </a:r>
           </a:p>
           <a:p>
@@ -11824,7 +11852,7 @@
                 </a:solidFill>
                 <a:latin typeface="Calibri"/>
               </a:rPr>
-              <a:t>Where the money went — outside the service-parts basket</a:t>
+              <a:t>Where the money went — outside the service-parts basket (FY)</a:t>
             </a:r>
           </a:p>
           <a:p>
@@ -11852,7 +11880,7 @@
                 </a:solidFill>
                 <a:latin typeface="Calibri"/>
               </a:rPr>
-              <a:t>Service parts: calendar-year capture vs network + fiscal-year billing</a:t>
+              <a:t>Service parts: CY capture vs network + FY billing (capture % is CY-only by design)</a:t>
             </a:r>
           </a:p>
           <a:p>
@@ -11880,7 +11908,7 @@
                 </a:solidFill>
                 <a:latin typeface="Calibri"/>
               </a:rPr>
-              <a:t>Brake pads — BVP share of total brake pad sales</a:t>
+              <a:t>Brake pads — BVP share of total brake pad sales (FY)</a:t>
             </a:r>
           </a:p>
           <a:p>
@@ -12127,7 +12155,7 @@
                 </a:solidFill>
                 <a:latin typeface="Calibri"/>
               </a:rPr>
-              <a:t>GPS: calendar year, fiscal year, and after warranty</a:t>
+              <a:t>GPS: fiscal year headline vs after warranty</a:t>
             </a:r>
           </a:p>
         </p:txBody>
@@ -12358,7 +12386,7 @@
                 </a:solidFill>
                 <a:latin typeface="Calibri"/>
               </a:rPr>
-              <a:t>Red = calendar-year GPS. Recent peak 42.0%; CY2025 = 35.4%.</a:t>
+              <a:t>Red = fiscal-year GPS (frozen CY2025 wallet). FY25 39.2% → FY26 37.1%.</a:t>
             </a:r>
           </a:p>
           <a:p>
@@ -12386,7 +12414,7 @@
                 </a:solidFill>
                 <a:latin typeface="Calibri"/>
               </a:rPr>
-              <a:t>Black = fiscal-year GPS (frozen CY2025 wallet). FY26 headline 37.1%.</a:t>
+              <a:t>Black = fiscal GPS after removing warranty parts (€). FY26 ≈ 26.1% (warranty EUR 102,418 ≈ 30% of FY26 billing).</a:t>
             </a:r>
           </a:p>
           <a:p>
@@ -12414,35 +12442,7 @@
                 </a:solidFill>
                 <a:latin typeface="Calibri"/>
               </a:rPr>
-              <a:t>Grey = fiscal GPS after removing warranty parts (€). FY26 ≈ 26.1% (warranty EUR 102,418 ≈ 30% of FY26 billing).</a:t>
-            </a:r>
-          </a:p>
-          <a:p>
-            <a:pPr>
-              <a:lnSpc>
-                <a:spcPct val="125000"/>
-              </a:lnSpc>
-              <a:spcAft>
-                <a:spcPts val="1000"/>
-              </a:spcAft>
-            </a:pPr>
-            <a:r>
-              <a:rPr sz="1250" b="1">
-                <a:solidFill>
-                  <a:srgbClr val="CC0E1E"/>
-                </a:solidFill>
-                <a:latin typeface="Calibri"/>
-              </a:rPr>
-              <a:t>—  </a:t>
-            </a:r>
-            <a:r>
-              <a:rPr sz="1250">
-                <a:solidFill>
-                  <a:srgbClr val="1A1A1A"/>
-                </a:solidFill>
-                <a:latin typeface="Calibri"/>
-              </a:rPr>
-              <a:t>Fleet 3,734 → 3,645 (working CY2026 estimate).</a:t>
+              <a:t>Fleet 3,734 → 3,645 (working year-end estimate under the FY2027 target).</a:t>
             </a:r>
           </a:p>
         </p:txBody>
@@ -13838,7 +13838,7 @@
                 </a:solidFill>
                 <a:latin typeface="Calibri"/>
               </a:rPr>
-              <a:t>Where the genuine drop sits (calendar 2024 → 2025)</a:t>
+              <a:t>Where the genuine drop sits (FY2025 → FY2026)</a:t>
             </a:r>
           </a:p>
         </p:txBody>
@@ -13967,7 +13967,7 @@
                 </a:solidFill>
                 <a:latin typeface="Calibri"/>
               </a:rPr>
-              <a:t>Genuine-only sales moved EUR -63,942 from CY2024 to CY2025.</a:t>
+              <a:t>Genuine-only sales moved EUR -31,719 from FY2025 to FY2026.</a:t>
             </a:r>
           </a:p>
           <a:p>
@@ -13995,7 +13995,7 @@
                 </a:solidFill>
                 <a:latin typeface="Calibri"/>
               </a:rPr>
-              <a:t>Of that, the routine service basket (filters, pads, rotors) moved EUR 10,265 on genuine-only; BVP in that basket moved EUR 4,072.</a:t>
+              <a:t>Of that, the routine service basket (filters, pads, rotors) moved EUR 7,633 on genuine-only; BVP in that basket moved EUR 3,835.</a:t>
             </a:r>
           </a:p>
           <a:p>
@@ -14023,7 +14023,7 @@
                 </a:solidFill>
                 <a:latin typeface="Calibri"/>
               </a:rPr>
-              <a:t>So about 116% of the genuine-only drop sits outside routine service parts.</a:t>
+              <a:t>So about 124% of the genuine-only drop sits outside routine service parts.</a:t>
             </a:r>
           </a:p>
           <a:p>
@@ -16507,7 +16507,7 @@
                 </a:solidFill>
                 <a:latin typeface="Calibri"/>
               </a:rPr>
-              <a:t>Brake pads — BVP share of total brake pad sales</a:t>
+              <a:t>Brake pads — BVP share of total brake pad sales (FY)</a:t>
             </a:r>
           </a:p>
         </p:txBody>
@@ -16650,7 +16650,7 @@
                           </a:solidFill>
                           <a:latin typeface="Calibri"/>
                         </a:rPr>
-                        <a:t>2024</a:t>
+                        <a:t>FY2025</a:t>
                       </a:r>
                     </a:p>
                   </a:txBody>
@@ -16673,7 +16673,7 @@
                           </a:solidFill>
                           <a:latin typeface="Calibri"/>
                         </a:rPr>
-                        <a:t>2025</a:t>
+                        <a:t>FY2026</a:t>
                       </a:r>
                     </a:p>
                   </a:txBody>
@@ -16886,7 +16886,7 @@
                           </a:solidFill>
                           <a:latin typeface="Calibri"/>
                         </a:rPr>
-                        <a:t>9%</a:t>
+                        <a:t>11%</a:t>
                       </a:r>
                     </a:p>
                   </a:txBody>

</xml_diff>

<commit_message>
Add largest-EUR PN drivers to commercial Parts Performance slides.
Category movers, decline deep-dives, and growth tables now name the top PN contributors (ex-warranty), with optional vehicle_model from BVP/PMS tables; rebuild all build-enabled sales-review decks.

Co-authored-by: Cursor <cursoragent@cursor.com>
</commit_message>
<xml_diff>
--- a/09_meetings/HUNGARY_Sales_Review_2026/ISZE_HUNGARY_Sales_Review_FY2027.pptx
+++ b/09_meetings/HUNGARY_Sales_Review_2026/ISZE_HUNGARY_Sales_Review_FY2027.pptx
@@ -10260,7 +10260,7 @@
                 </a:solidFill>
                 <a:latin typeface="Calibri"/>
               </a:rPr>
-              <a:t>Brake parts / Injectors / Turbo: agree which category we tackle first, and what the joint action is.</a:t>
+              <a:t>Brake parts / Steering / Turbo: agree which category we tackle first, and what the joint action is.</a:t>
             </a:r>
           </a:p>
           <a:p>
@@ -10692,7 +10692,7 @@
                 </a:solidFill>
                 <a:latin typeface="Calibri"/>
               </a:rPr>
-              <a:t>Parts Performance — Injectors</a:t>
+              <a:t>Parts Performance — Steering</a:t>
             </a:r>
           </a:p>
           <a:p>
@@ -16029,7 +16029,7 @@
                 </a:solidFill>
                 <a:latin typeface="Calibri"/>
               </a:rPr>
-              <a:t>Parts Performance — CY H1 2026 vs CY H1 2025</a:t>
+              <a:t>Parts Performance — CY H1 2026 vs CY H1 2025 (commercial, ex-warranty)</a:t>
             </a:r>
           </a:p>
         </p:txBody>
@@ -16260,7 +16260,7 @@
                 </a:solidFill>
                 <a:latin typeface="Calibri"/>
               </a:rPr>
-              <a:t>Parts billing EUR 171K against EUR 169K a year earlier — +0.9%. After EUR 1K of credit notes the net figure is EUR 170K.</a:t>
+              <a:t>Commercial parts billing (warranty/campaign excluded) EUR 123K against EUR 122K a year earlier — +0.3% (CY H1 2026 vs CY H1 2025, Jan–Jun).</a:t>
             </a:r>
           </a:p>
           <a:p>
@@ -16288,7 +16288,7 @@
                 </a:solidFill>
                 <a:latin typeface="Calibri"/>
               </a:rPr>
-              <a:t>Biggest declines: Brake parts EUR -9K; Injectors EUR -2K; Turbo EUR -1K.</a:t>
+              <a:t>Largest PN drops: 8983767550 (ROTOR; DISC BRK,FRT) EUR -6K, 79 fewer pcs; 8977993753 (LAMP ASM; HEAD) EUR -3K, 9 fewer pcs; 8975546610 (PAD KIT; CALIPER,DIS) [TF*] EUR -2K, 21 fewer pcs.</a:t>
             </a:r>
           </a:p>
           <a:p>
@@ -16316,7 +16316,7 @@
                 </a:solidFill>
                 <a:latin typeface="Calibri"/>
               </a:rPr>
-              <a:t>Growing: Air conditioning +39%, Electrical sensors +20%, Body parts +9%.</a:t>
+              <a:t>Largest PN gains: 8974995480 (FILTER; ACL) [TFR,TFS,UCR,UCS] EUR 3K, 154 more pcs; 1884057520 (T AXLE OIL  20L) EUR 2K, 14 more pcs; 8975595830 (PANEL; SIDE GATE) EUR 2K, 8 more pcs.</a:t>
             </a:r>
           </a:p>
           <a:p>
@@ -16344,7 +16344,7 @@
                 </a:solidFill>
                 <a:latin typeface="Calibri"/>
               </a:rPr>
-              <a:t>CY H1 2026 against CY H1 2025 (calendar Jan–Jun, Q1+Q2) — like-for-like half-year cut.</a:t>
+              <a:t>Credit notes of EUR 1K stay on the net bridge (net EUR 170K); not in the movers.</a:t>
             </a:r>
           </a:p>
         </p:txBody>
@@ -19223,7 +19223,7 @@
                 </a:solidFill>
                 <a:latin typeface="Calibri"/>
               </a:rPr>
-              <a:t>Brake parts — CY H1 2026 vs CY H1 2025</a:t>
+              <a:t>Brake parts — CY H1 2026 vs CY H1 2025 (commercial, ex-warranty)</a:t>
             </a:r>
           </a:p>
         </p:txBody>
@@ -19337,7 +19337,7 @@
               </a:spcAft>
             </a:pPr>
             <a:r>
-              <a:rPr sz="1400" b="1">
+              <a:rPr sz="1300" b="1">
                 <a:solidFill>
                   <a:srgbClr val="CC0E1E"/>
                 </a:solidFill>
@@ -19346,13 +19346,13 @@
               <a:t>—  </a:t>
             </a:r>
             <a:r>
-              <a:rPr sz="1400">
+              <a:rPr sz="1300">
                 <a:solidFill>
                   <a:srgbClr val="1A1A1A"/>
                 </a:solidFill>
                 <a:latin typeface="Calibri"/>
               </a:rPr>
-              <a:t>EUR 22,944 (CY H1 2025) to EUR 13,910 (CY H1 2026), down EUR 9,034 (-39%).</a:t>
+              <a:t>EUR 18,443 (CY H1 2025) to EUR 10,718 (CY H1 2026), down EUR 7,725 (-42%).</a:t>
             </a:r>
           </a:p>
           <a:p>
@@ -19365,7 +19365,7 @@
               </a:spcAft>
             </a:pPr>
             <a:r>
-              <a:rPr sz="1400" b="1">
+              <a:rPr sz="1300" b="1">
                 <a:solidFill>
                   <a:srgbClr val="CC0E1E"/>
                 </a:solidFill>
@@ -19374,13 +19374,13 @@
               <a:t>—  </a:t>
             </a:r>
             <a:r>
-              <a:rPr sz="1400">
+              <a:rPr sz="1300">
                 <a:solidFill>
                   <a:srgbClr val="1A1A1A"/>
                 </a:solidFill>
                 <a:latin typeface="Calibri"/>
               </a:rPr>
-              <a:t>8983767550 (ROTOR; DISC BRK,FRT): EUR 11,764 to EUR 5,544, 79 fewer pieces.</a:t>
+              <a:t>Largest part numbers driving the decline (by EUR):</a:t>
             </a:r>
           </a:p>
           <a:p>
@@ -19393,7 +19393,7 @@
               </a:spcAft>
             </a:pPr>
             <a:r>
-              <a:rPr sz="1400" b="1">
+              <a:rPr sz="1300" b="1">
                 <a:solidFill>
                   <a:srgbClr val="CC0E1E"/>
                 </a:solidFill>
@@ -19402,13 +19402,13 @@
               <a:t>—  </a:t>
             </a:r>
             <a:r>
-              <a:rPr sz="1400">
+              <a:rPr sz="1300">
                 <a:solidFill>
                   <a:srgbClr val="1A1A1A"/>
                 </a:solidFill>
                 <a:latin typeface="Calibri"/>
               </a:rPr>
-              <a:t>8975056801 (PAD KIT; CALIPER,DISC BRK,FRT): EUR 4,501 to EUR 2,561, 23 fewer pieces.</a:t>
+              <a:t>8983767550 (ROTOR; DISC BRK,FRT): EUR 11,764 to EUR 5,544, 79 fewer pieces.</a:t>
             </a:r>
           </a:p>
           <a:p>
@@ -19421,7 +19421,7 @@
               </a:spcAft>
             </a:pPr>
             <a:r>
-              <a:rPr sz="1400" b="1">
+              <a:rPr sz="1300" b="1">
                 <a:solidFill>
                   <a:srgbClr val="CC0E1E"/>
                 </a:solidFill>
@@ -19430,13 +19430,69 @@
               <a:t>—  </a:t>
             </a:r>
             <a:r>
-              <a:rPr sz="1400">
+              <a:rPr sz="1300">
                 <a:solidFill>
                   <a:srgbClr val="1A1A1A"/>
                 </a:solidFill>
                 <a:latin typeface="Calibri"/>
               </a:rPr>
-              <a:t>8975546610 (PAD KIT; CALIPER,DISC BRK,FRT): EUR 2,500 to EUR 742, 21 fewer pieces.</a:t>
+              <a:t>8975546610 (PAD KIT; CALIPER,DISC BRK,FRT · TF*): EUR 2,500 to EUR 742, 21 fewer pieces.</a:t>
+            </a:r>
+          </a:p>
+          <a:p>
+            <a:pPr>
+              <a:lnSpc>
+                <a:spcPct val="125000"/>
+              </a:lnSpc>
+              <a:spcAft>
+                <a:spcPts val="1000"/>
+              </a:spcAft>
+            </a:pPr>
+            <a:r>
+              <a:rPr sz="1300" b="1">
+                <a:solidFill>
+                  <a:srgbClr val="CC0E1E"/>
+                </a:solidFill>
+                <a:latin typeface="Calibri"/>
+              </a:rPr>
+              <a:t>—  </a:t>
+            </a:r>
+            <a:r>
+              <a:rPr sz="1300">
+                <a:solidFill>
+                  <a:srgbClr val="1A1A1A"/>
+                </a:solidFill>
+                <a:latin typeface="Calibri"/>
+              </a:rPr>
+              <a:t>8978279610 (PAD KIT; DISC BRK,W/O SHIM &amp; CLIP): EUR 2,015 to EUR 1,311, 10 fewer pieces.</a:t>
+            </a:r>
+          </a:p>
+          <a:p>
+            <a:pPr>
+              <a:lnSpc>
+                <a:spcPct val="125000"/>
+              </a:lnSpc>
+              <a:spcAft>
+                <a:spcPts val="1000"/>
+              </a:spcAft>
+            </a:pPr>
+            <a:r>
+              <a:rPr sz="1300" b="1">
+                <a:solidFill>
+                  <a:srgbClr val="CC0E1E"/>
+                </a:solidFill>
+                <a:latin typeface="Calibri"/>
+              </a:rPr>
+              <a:t>—  </a:t>
+            </a:r>
+            <a:r>
+              <a:rPr sz="1300">
+                <a:solidFill>
+                  <a:srgbClr val="1A1A1A"/>
+                </a:solidFill>
+                <a:latin typeface="Calibri"/>
+              </a:rPr>
+              <a:t>8976526220 (PAD KIT; CALIPER,DISC BRK,FRT): EUR 644 to EUR 0, 10 fewer pieces.</a:t>
             </a:r>
           </a:p>
         </p:txBody>
@@ -19706,7 +19762,7 @@
                 </a:solidFill>
                 <a:latin typeface="Calibri"/>
               </a:rPr>
-              <a:t>PARTS PERFORMANCE — INJECTORS</a:t>
+              <a:t>PARTS PERFORMANCE — STEERING</a:t>
             </a:r>
           </a:p>
         </p:txBody>
@@ -19741,7 +19797,7 @@
                 </a:solidFill>
                 <a:latin typeface="Calibri"/>
               </a:rPr>
-              <a:t>Injectors — CY H1 2026 vs CY H1 2025</a:t>
+              <a:t>Steering — CY H1 2026 vs CY H1 2025 (commercial, ex-warranty)</a:t>
             </a:r>
           </a:p>
         </p:txBody>
@@ -19855,7 +19911,7 @@
               </a:spcAft>
             </a:pPr>
             <a:r>
-              <a:rPr sz="1400" b="1">
+              <a:rPr sz="1300" b="1">
                 <a:solidFill>
                   <a:srgbClr val="CC0E1E"/>
                 </a:solidFill>
@@ -19864,13 +19920,13 @@
               <a:t>—  </a:t>
             </a:r>
             <a:r>
-              <a:rPr sz="1400">
+              <a:rPr sz="1300">
                 <a:solidFill>
                   <a:srgbClr val="1A1A1A"/>
                 </a:solidFill>
                 <a:latin typeface="Calibri"/>
               </a:rPr>
-              <a:t>EUR 3,090 (CY H1 2025) to EUR 1,525 (CY H1 2026), down EUR 1,565 (-51%).</a:t>
+              <a:t>EUR 2,096 (CY H1 2025) to EUR 991 (CY H1 2026), down EUR 1,105 (-53%).</a:t>
             </a:r>
           </a:p>
           <a:p>
@@ -19883,7 +19939,7 @@
               </a:spcAft>
             </a:pPr>
             <a:r>
-              <a:rPr sz="1400" b="1">
+              <a:rPr sz="1300" b="1">
                 <a:solidFill>
                   <a:srgbClr val="CC0E1E"/>
                 </a:solidFill>
@@ -19892,73 +19948,15 @@
               <a:t>—  </a:t>
             </a:r>
             <a:r>
-              <a:rPr sz="1400">
+              <a:rPr sz="1300">
                 <a:solidFill>
                   <a:srgbClr val="1A1A1A"/>
                 </a:solidFill>
                 <a:latin typeface="Calibri"/>
               </a:rPr>
-              <a:t>8983842670 (INJECTOR ASM; DEF DCM): EUR 2,051 to EUR 632, 9 fewer pieces.</a:t>
-            </a:r>
-          </a:p>
-        </p:txBody>
-      </p:sp>
-      <p:sp>
-        <p:nvSpPr>
-          <p:cNvPr id="9" name="TextBox 8"/>
-          <p:cNvSpPr txBox="1"/>
-          <p:nvPr/>
-        </p:nvSpPr>
-        <p:spPr>
-          <a:xfrm>
-            <a:off x="292608" y="3840480"/>
-            <a:ext cx="8595360" cy="274320"/>
-          </a:xfrm>
-          <a:prstGeom prst="rect">
-            <a:avLst/>
-          </a:prstGeom>
-          <a:noFill/>
-        </p:spPr>
-        <p:txBody>
-          <a:bodyPr wrap="square">
-            <a:spAutoFit/>
-          </a:bodyPr>
-          <a:lstStyle/>
-          <a:p>
-            <a:pPr algn="l"/>
-            <a:r>
-              <a:rPr sz="1300" b="1">
-                <a:solidFill>
-                  <a:srgbClr val="CC0E1E"/>
-                </a:solidFill>
-                <a:latin typeface="Calibri"/>
-              </a:rPr>
-              <a:t>Questions for us to work through together</a:t>
-            </a:r>
-          </a:p>
-        </p:txBody>
-      </p:sp>
-      <p:sp>
-        <p:nvSpPr>
-          <p:cNvPr id="10" name="TextBox 9"/>
-          <p:cNvSpPr txBox="1"/>
-          <p:nvPr/>
-        </p:nvSpPr>
-        <p:spPr>
-          <a:xfrm>
-            <a:off x="292608" y="4160520"/>
-            <a:ext cx="11612880" cy="1737360"/>
-          </a:xfrm>
-          <a:prstGeom prst="rect">
-            <a:avLst/>
-          </a:prstGeom>
-          <a:noFill/>
-        </p:spPr>
-        <p:txBody>
-          <a:bodyPr wrap="square">
-            <a:spAutoFit/>
-          </a:bodyPr>
-          <a:lstStyle/>
+              <a:t>Largest part numbers driving the decline (by EUR):</a:t>
+            </a:r>
+          </a:p>
           <a:p>
             <a:pPr>
               <a:lnSpc>
@@ -19969,7 +19967,7 @@
               </a:spcAft>
             </a:pPr>
             <a:r>
-              <a:rPr sz="1400" b="1">
+              <a:rPr sz="1300" b="1">
                 <a:solidFill>
                   <a:srgbClr val="CC0E1E"/>
                 </a:solidFill>
@@ -19978,13 +19976,13 @@
               <a:t>—  </a:t>
             </a:r>
             <a:r>
-              <a:rPr sz="1400">
+              <a:rPr sz="1300">
                 <a:solidFill>
                   <a:srgbClr val="1A1A1A"/>
                 </a:solidFill>
                 <a:latin typeface="Calibri"/>
               </a:rPr>
-              <a:t>Is this fewer failures, or repairs moving out of the network?</a:t>
+              <a:t>8979461321 (STEERING UNIT): EUR 624 to EUR 0, 1 fewer pieces.</a:t>
             </a:r>
           </a:p>
           <a:p>
@@ -19997,7 +19995,7 @@
               </a:spcAft>
             </a:pPr>
             <a:r>
-              <a:rPr sz="1400" b="1">
+              <a:rPr sz="1300" b="1">
                 <a:solidFill>
                   <a:srgbClr val="CC0E1E"/>
                 </a:solidFill>
@@ -20006,13 +20004,13 @@
               <a:t>—  </a:t>
             </a:r>
             <a:r>
-              <a:rPr sz="1400">
+              <a:rPr sz="1300">
                 <a:solidFill>
                   <a:srgbClr val="1A1A1A"/>
                 </a:solidFill>
                 <a:latin typeface="Calibri"/>
               </a:rPr>
-              <a:t>Is the exchange/reman route competing with new parts here?</a:t>
+              <a:t>8979461642 (PUMP ASM; OIL,P/S): EUR 465 to EUR 0, 2 fewer pieces.</a:t>
             </a:r>
           </a:p>
           <a:p>
@@ -20025,6 +20023,120 @@
               </a:spcAft>
             </a:pPr>
             <a:r>
+              <a:rPr sz="1300" b="1">
+                <a:solidFill>
+                  <a:srgbClr val="CC0E1E"/>
+                </a:solidFill>
+                <a:latin typeface="Calibri"/>
+              </a:rPr>
+              <a:t>—  </a:t>
+            </a:r>
+            <a:r>
+              <a:rPr sz="1300">
+                <a:solidFill>
+                  <a:srgbClr val="1A1A1A"/>
+                </a:solidFill>
+                <a:latin typeface="Calibri"/>
+              </a:rPr>
+              <a:t>7552338510 (KNUCKLE; FRT AXLE): EUR 257 to EUR 0, 1 fewer pieces.</a:t>
+            </a:r>
+          </a:p>
+          <a:p>
+            <a:pPr>
+              <a:lnSpc>
+                <a:spcPct val="125000"/>
+              </a:lnSpc>
+              <a:spcAft>
+                <a:spcPts val="1000"/>
+              </a:spcAft>
+            </a:pPr>
+            <a:r>
+              <a:rPr sz="1300" b="1">
+                <a:solidFill>
+                  <a:srgbClr val="CC0E1E"/>
+                </a:solidFill>
+                <a:latin typeface="Calibri"/>
+              </a:rPr>
+              <a:t>—  </a:t>
+            </a:r>
+            <a:r>
+              <a:rPr sz="1300">
+                <a:solidFill>
+                  <a:srgbClr val="1A1A1A"/>
+                </a:solidFill>
+                <a:latin typeface="Calibri"/>
+              </a:rPr>
+              <a:t>8983039040 (KNUCKLE; FRT AXLE): EUR 186 to EUR 0, 1 fewer pieces.</a:t>
+            </a:r>
+          </a:p>
+        </p:txBody>
+      </p:sp>
+      <p:sp>
+        <p:nvSpPr>
+          <p:cNvPr id="9" name="TextBox 8"/>
+          <p:cNvSpPr txBox="1"/>
+          <p:nvPr/>
+        </p:nvSpPr>
+        <p:spPr>
+          <a:xfrm>
+            <a:off x="292608" y="3840480"/>
+            <a:ext cx="8595360" cy="274320"/>
+          </a:xfrm>
+          <a:prstGeom prst="rect">
+            <a:avLst/>
+          </a:prstGeom>
+          <a:noFill/>
+        </p:spPr>
+        <p:txBody>
+          <a:bodyPr wrap="square">
+            <a:spAutoFit/>
+          </a:bodyPr>
+          <a:lstStyle/>
+          <a:p>
+            <a:pPr algn="l"/>
+            <a:r>
+              <a:rPr sz="1300" b="1">
+                <a:solidFill>
+                  <a:srgbClr val="CC0E1E"/>
+                </a:solidFill>
+                <a:latin typeface="Calibri"/>
+              </a:rPr>
+              <a:t>Questions for us to work through together</a:t>
+            </a:r>
+          </a:p>
+        </p:txBody>
+      </p:sp>
+      <p:sp>
+        <p:nvSpPr>
+          <p:cNvPr id="10" name="TextBox 9"/>
+          <p:cNvSpPr txBox="1"/>
+          <p:nvPr/>
+        </p:nvSpPr>
+        <p:spPr>
+          <a:xfrm>
+            <a:off x="292608" y="4160520"/>
+            <a:ext cx="11612880" cy="1737360"/>
+          </a:xfrm>
+          <a:prstGeom prst="rect">
+            <a:avLst/>
+          </a:prstGeom>
+          <a:noFill/>
+        </p:spPr>
+        <p:txBody>
+          <a:bodyPr wrap="square">
+            <a:spAutoFit/>
+          </a:bodyPr>
+          <a:lstStyle/>
+          <a:p>
+            <a:pPr>
+              <a:lnSpc>
+                <a:spcPct val="125000"/>
+              </a:lnSpc>
+              <a:spcAft>
+                <a:spcPts val="1000"/>
+              </a:spcAft>
+            </a:pPr>
+            <a:r>
               <a:rPr sz="1400" b="1">
                 <a:solidFill>
                   <a:srgbClr val="CC0E1E"/>
@@ -20040,7 +20152,63 @@
                 </a:solidFill>
                 <a:latin typeface="Calibri"/>
               </a:rPr>
-              <a:t>Are dealers still quoting these part numbers, or have they dropped off the workshop menu?</a:t>
+              <a:t>Is this pricing against what the dealers can buy locally?</a:t>
+            </a:r>
+          </a:p>
+          <a:p>
+            <a:pPr>
+              <a:lnSpc>
+                <a:spcPct val="125000"/>
+              </a:lnSpc>
+              <a:spcAft>
+                <a:spcPts val="1000"/>
+              </a:spcAft>
+            </a:pPr>
+            <a:r>
+              <a:rPr sz="1400" b="1">
+                <a:solidFill>
+                  <a:srgbClr val="CC0E1E"/>
+                </a:solidFill>
+                <a:latin typeface="Calibri"/>
+              </a:rPr>
+              <a:t>—  </a:t>
+            </a:r>
+            <a:r>
+              <a:rPr sz="1400">
+                <a:solidFill>
+                  <a:srgbClr val="1A1A1A"/>
+                </a:solidFill>
+                <a:latin typeface="Calibri"/>
+              </a:rPr>
+              <a:t>Is any of this stock timing on your side rather than end demand?</a:t>
+            </a:r>
+          </a:p>
+          <a:p>
+            <a:pPr>
+              <a:lnSpc>
+                <a:spcPct val="125000"/>
+              </a:lnSpc>
+              <a:spcAft>
+                <a:spcPts val="1000"/>
+              </a:spcAft>
+            </a:pPr>
+            <a:r>
+              <a:rPr sz="1400" b="1">
+                <a:solidFill>
+                  <a:srgbClr val="CC0E1E"/>
+                </a:solidFill>
+                <a:latin typeface="Calibri"/>
+              </a:rPr>
+              <a:t>—  </a:t>
+            </a:r>
+            <a:r>
+              <a:rPr sz="1400">
+                <a:solidFill>
+                  <a:srgbClr val="1A1A1A"/>
+                </a:solidFill>
+                <a:latin typeface="Calibri"/>
+              </a:rPr>
+              <a:t>What would make the biggest difference to keep this business with us?</a:t>
             </a:r>
           </a:p>
         </p:txBody>
@@ -20203,7 +20371,7 @@
                 </a:solidFill>
                 <a:latin typeface="Calibri"/>
               </a:rPr>
-              <a:t>Turbo — CY H1 2026 vs CY H1 2025</a:t>
+              <a:t>Turbo — CY H1 2026 vs CY H1 2025 (commercial, ex-warranty)</a:t>
             </a:r>
           </a:p>
         </p:txBody>
@@ -20317,7 +20485,7 @@
               </a:spcAft>
             </a:pPr>
             <a:r>
-              <a:rPr sz="1400" b="1">
+              <a:rPr sz="1300" b="1">
                 <a:solidFill>
                   <a:srgbClr val="CC0E1E"/>
                 </a:solidFill>
@@ -20326,13 +20494,153 @@
               <a:t>—  </a:t>
             </a:r>
             <a:r>
-              <a:rPr sz="1400">
+              <a:rPr sz="1300">
                 <a:solidFill>
                   <a:srgbClr val="1A1A1A"/>
                 </a:solidFill>
                 <a:latin typeface="Calibri"/>
               </a:rPr>
               <a:t>EUR 1,059 (CY H1 2025) to EUR 12 (CY H1 2026), down EUR 1,047 (-99%).</a:t>
+            </a:r>
+          </a:p>
+          <a:p>
+            <a:pPr>
+              <a:lnSpc>
+                <a:spcPct val="125000"/>
+              </a:lnSpc>
+              <a:spcAft>
+                <a:spcPts val="1000"/>
+              </a:spcAft>
+            </a:pPr>
+            <a:r>
+              <a:rPr sz="1300" b="1">
+                <a:solidFill>
+                  <a:srgbClr val="CC0E1E"/>
+                </a:solidFill>
+                <a:latin typeface="Calibri"/>
+              </a:rPr>
+              <a:t>—  </a:t>
+            </a:r>
+            <a:r>
+              <a:rPr sz="1300">
+                <a:solidFill>
+                  <a:srgbClr val="1A1A1A"/>
+                </a:solidFill>
+                <a:latin typeface="Calibri"/>
+              </a:rPr>
+              <a:t>Largest part numbers driving the decline (by EUR):</a:t>
+            </a:r>
+          </a:p>
+          <a:p>
+            <a:pPr>
+              <a:lnSpc>
+                <a:spcPct val="125000"/>
+              </a:lnSpc>
+              <a:spcAft>
+                <a:spcPts val="1000"/>
+              </a:spcAft>
+            </a:pPr>
+            <a:r>
+              <a:rPr sz="1300" b="1">
+                <a:solidFill>
+                  <a:srgbClr val="CC0E1E"/>
+                </a:solidFill>
+                <a:latin typeface="Calibri"/>
+              </a:rPr>
+              <a:t>—  </a:t>
+            </a:r>
+            <a:r>
+              <a:rPr sz="1300">
+                <a:solidFill>
+                  <a:srgbClr val="1A1A1A"/>
+                </a:solidFill>
+                <a:latin typeface="Calibri"/>
+              </a:rPr>
+              <a:t>8974985741 (TURBOCHARGER ASM): EUR 857 to EUR 0, 1 fewer pieces.</a:t>
+            </a:r>
+          </a:p>
+          <a:p>
+            <a:pPr>
+              <a:lnSpc>
+                <a:spcPct val="125000"/>
+              </a:lnSpc>
+              <a:spcAft>
+                <a:spcPts val="1000"/>
+              </a:spcAft>
+            </a:pPr>
+            <a:r>
+              <a:rPr sz="1300" b="1">
+                <a:solidFill>
+                  <a:srgbClr val="CC0E1E"/>
+                </a:solidFill>
+                <a:latin typeface="Calibri"/>
+              </a:rPr>
+              <a:t>—  </a:t>
+            </a:r>
+            <a:r>
+              <a:rPr sz="1300">
+                <a:solidFill>
+                  <a:srgbClr val="1A1A1A"/>
+                </a:solidFill>
+                <a:latin typeface="Calibri"/>
+              </a:rPr>
+              <a:t>8975334720 (PIPE; OIL RETURN,TURBOCHARGER): EUR 119 to EUR 0, 2 fewer pieces.</a:t>
+            </a:r>
+          </a:p>
+          <a:p>
+            <a:pPr>
+              <a:lnSpc>
+                <a:spcPct val="125000"/>
+              </a:lnSpc>
+              <a:spcAft>
+                <a:spcPts val="1000"/>
+              </a:spcAft>
+            </a:pPr>
+            <a:r>
+              <a:rPr sz="1300" b="1">
+                <a:solidFill>
+                  <a:srgbClr val="CC0E1E"/>
+                </a:solidFill>
+                <a:latin typeface="Calibri"/>
+              </a:rPr>
+              <a:t>—  </a:t>
+            </a:r>
+            <a:r>
+              <a:rPr sz="1300">
+                <a:solidFill>
+                  <a:srgbClr val="1A1A1A"/>
+                </a:solidFill>
+                <a:latin typeface="Calibri"/>
+              </a:rPr>
+              <a:t>8981993530 (SENSOR; TURBOCHARGER): EUR 48 to EUR 0, 1 fewer pieces.</a:t>
+            </a:r>
+          </a:p>
+          <a:p>
+            <a:pPr>
+              <a:lnSpc>
+                <a:spcPct val="125000"/>
+              </a:lnSpc>
+              <a:spcAft>
+                <a:spcPts val="1000"/>
+              </a:spcAft>
+            </a:pPr>
+            <a:r>
+              <a:rPr sz="1300" b="1">
+                <a:solidFill>
+                  <a:srgbClr val="CC0E1E"/>
+                </a:solidFill>
+                <a:latin typeface="Calibri"/>
+              </a:rPr>
+              <a:t>—  </a:t>
+            </a:r>
+            <a:r>
+              <a:rPr sz="1300">
+                <a:solidFill>
+                  <a:srgbClr val="1A1A1A"/>
+                </a:solidFill>
+                <a:latin typeface="Calibri"/>
+              </a:rPr>
+              <a:t>8982480882 (GASKET; TURBOCHARGER TO EXH MANIF): EUR 20 to EUR 0, 5 fewer pieces.</a:t>
             </a:r>
           </a:p>
         </p:txBody>
@@ -20637,7 +20945,7 @@
                 </a:solidFill>
                 <a:latin typeface="Calibri"/>
               </a:rPr>
-              <a:t>Where volume grew — CY H1 2026 vs CY H1 2025</a:t>
+              <a:t>Where volume grew — CY H1 2026 vs CY H1 2025 (commercial, ex-warranty)</a:t>
             </a:r>
           </a:p>
         </p:txBody>
@@ -20739,10 +21047,12 @@
                 <a:tableStyleId>{5C22544A-7EE6-4342-B048-85BDC9FD1C3A}</a:tableStyleId>
               </a:tblPr>
               <a:tblGrid>
-                <a:gridCol w="2194560"/>
-                <a:gridCol w="4480560"/>
-                <a:gridCol w="2468880"/>
-                <a:gridCol w="2468880"/>
+                <a:gridCol w="1737360"/>
+                <a:gridCol w="2926080"/>
+                <a:gridCol w="1645920"/>
+                <a:gridCol w="1737360"/>
+                <a:gridCol w="1737360"/>
+                <a:gridCol w="1828800"/>
               </a:tblGrid>
               <a:tr h="339634">
                 <a:tc>
@@ -20752,7 +21062,7 @@
                     <a:p>
                       <a:pPr algn="l"/>
                       <a:r>
-                        <a:rPr sz="1200" b="1">
+                        <a:rPr sz="1100" b="1">
                           <a:solidFill>
                             <a:srgbClr val="FFFFFF"/>
                           </a:solidFill>
@@ -20775,7 +21085,7 @@
                     <a:p>
                       <a:pPr algn="l"/>
                       <a:r>
-                        <a:rPr sz="1200" b="1">
+                        <a:rPr sz="1100" b="1">
                           <a:solidFill>
                             <a:srgbClr val="FFFFFF"/>
                           </a:solidFill>
@@ -20796,9 +21106,32 @@
                     <a:bodyPr/>
                     <a:lstStyle/>
                     <a:p>
+                      <a:pPr algn="l"/>
+                      <a:r>
+                        <a:rPr sz="1100" b="1">
+                          <a:solidFill>
+                            <a:srgbClr val="FFFFFF"/>
+                          </a:solidFill>
+                          <a:latin typeface="Calibri"/>
+                        </a:rPr>
+                        <a:t>Model</a:t>
+                      </a:r>
+                    </a:p>
+                  </a:txBody>
+                  <a:tcPr anchor="ctr" marL="73152" marR="73152">
+                    <a:solidFill>
+                      <a:srgbClr val="CC0E1E"/>
+                    </a:solidFill>
+                  </a:tcPr>
+                </a:tc>
+                <a:tc>
+                  <a:txBody>
+                    <a:bodyPr/>
+                    <a:lstStyle/>
+                    <a:p>
                       <a:pPr algn="r"/>
                       <a:r>
-                        <a:rPr sz="1200" b="1">
+                        <a:rPr sz="1100" b="1">
                           <a:solidFill>
                             <a:srgbClr val="FFFFFF"/>
                           </a:solidFill>
@@ -20821,13 +21154,36 @@
                     <a:p>
                       <a:pPr algn="r"/>
                       <a:r>
-                        <a:rPr sz="1200" b="1">
+                        <a:rPr sz="1100" b="1">
                           <a:solidFill>
                             <a:srgbClr val="FFFFFF"/>
                           </a:solidFill>
                           <a:latin typeface="Calibri"/>
                         </a:rPr>
                         <a:t>CY H1 2026</a:t>
+                      </a:r>
+                    </a:p>
+                  </a:txBody>
+                  <a:tcPr anchor="ctr" marL="73152" marR="73152">
+                    <a:solidFill>
+                      <a:srgbClr val="CC0E1E"/>
+                    </a:solidFill>
+                  </a:tcPr>
+                </a:tc>
+                <a:tc>
+                  <a:txBody>
+                    <a:bodyPr/>
+                    <a:lstStyle/>
+                    <a:p>
+                      <a:pPr algn="r"/>
+                      <a:r>
+                        <a:rPr sz="1100" b="1">
+                          <a:solidFill>
+                            <a:srgbClr val="FFFFFF"/>
+                          </a:solidFill>
+                          <a:latin typeface="Calibri"/>
+                        </a:rPr>
+                        <a:t>Δ EUR</a:t>
                       </a:r>
                     </a:p>
                   </a:txBody>
@@ -20846,7 +21202,7 @@
                     <a:p>
                       <a:pPr algn="l"/>
                       <a:r>
-                        <a:rPr sz="1200" b="0">
+                        <a:rPr sz="1100" b="0">
                           <a:solidFill>
                             <a:srgbClr val="1A1A1A"/>
                           </a:solidFill>
@@ -20869,7 +21225,7 @@
                     <a:p>
                       <a:pPr algn="l"/>
                       <a:r>
-                        <a:rPr sz="1200" b="0">
+                        <a:rPr sz="1100" b="0">
                           <a:solidFill>
                             <a:srgbClr val="1A1A1A"/>
                           </a:solidFill>
@@ -20890,9 +21246,32 @@
                     <a:bodyPr/>
                     <a:lstStyle/>
                     <a:p>
+                      <a:pPr algn="l"/>
+                      <a:r>
+                        <a:rPr sz="1100" b="0">
+                          <a:solidFill>
+                            <a:srgbClr val="1A1A1A"/>
+                          </a:solidFill>
+                          <a:latin typeface="Calibri"/>
+                        </a:rPr>
+                        <a:t>TFR,TFS,UCR,UCS</a:t>
+                      </a:r>
+                    </a:p>
+                  </a:txBody>
+                  <a:tcPr anchor="ctr" marL="73152" marR="73152">
+                    <a:solidFill>
+                      <a:srgbClr val="FFFFFF"/>
+                    </a:solidFill>
+                  </a:tcPr>
+                </a:tc>
+                <a:tc>
+                  <a:txBody>
+                    <a:bodyPr/>
+                    <a:lstStyle/>
+                    <a:p>
                       <a:pPr algn="r"/>
                       <a:r>
-                        <a:rPr sz="1200" b="0">
+                        <a:rPr sz="1100" b="0">
                           <a:solidFill>
                             <a:srgbClr val="1A1A1A"/>
                           </a:solidFill>
@@ -20915,13 +21294,36 @@
                     <a:p>
                       <a:pPr algn="r"/>
                       <a:r>
-                        <a:rPr sz="1200" b="0">
+                        <a:rPr sz="1100" b="0">
                           <a:solidFill>
                             <a:srgbClr val="1A1A1A"/>
                           </a:solidFill>
                           <a:latin typeface="Calibri"/>
                         </a:rPr>
                         <a:t>EUR 8,390</a:t>
+                      </a:r>
+                    </a:p>
+                  </a:txBody>
+                  <a:tcPr anchor="ctr" marL="73152" marR="73152">
+                    <a:solidFill>
+                      <a:srgbClr val="FFFFFF"/>
+                    </a:solidFill>
+                  </a:tcPr>
+                </a:tc>
+                <a:tc>
+                  <a:txBody>
+                    <a:bodyPr/>
+                    <a:lstStyle/>
+                    <a:p>
+                      <a:pPr algn="r"/>
+                      <a:r>
+                        <a:rPr sz="1100" b="0">
+                          <a:solidFill>
+                            <a:srgbClr val="1A1A1A"/>
+                          </a:solidFill>
+                          <a:latin typeface="Calibri"/>
+                        </a:rPr>
+                        <a:t>EUR 3,237</a:t>
                       </a:r>
                     </a:p>
                   </a:txBody>
@@ -20940,7 +21342,7 @@
                     <a:p>
                       <a:pPr algn="l"/>
                       <a:r>
-                        <a:rPr sz="1200" b="0">
+                        <a:rPr sz="1100" b="0">
                           <a:solidFill>
                             <a:srgbClr val="1A1A1A"/>
                           </a:solidFill>
@@ -20963,7 +21365,7 @@
                     <a:p>
                       <a:pPr algn="l"/>
                       <a:r>
-                        <a:rPr sz="1200" b="0">
+                        <a:rPr sz="1100" b="0">
                           <a:solidFill>
                             <a:srgbClr val="1A1A1A"/>
                           </a:solidFill>
@@ -20984,9 +21386,32 @@
                     <a:bodyPr/>
                     <a:lstStyle/>
                     <a:p>
+                      <a:pPr algn="l"/>
+                      <a:r>
+                        <a:rPr sz="1100" b="0">
+                          <a:solidFill>
+                            <a:srgbClr val="1A1A1A"/>
+                          </a:solidFill>
+                          <a:latin typeface="Calibri"/>
+                        </a:rPr>
+                        <a:t>—</a:t>
+                      </a:r>
+                    </a:p>
+                  </a:txBody>
+                  <a:tcPr anchor="ctr" marL="73152" marR="73152">
+                    <a:solidFill>
+                      <a:srgbClr val="ECECEC"/>
+                    </a:solidFill>
+                  </a:tcPr>
+                </a:tc>
+                <a:tc>
+                  <a:txBody>
+                    <a:bodyPr/>
+                    <a:lstStyle/>
+                    <a:p>
                       <a:pPr algn="r"/>
                       <a:r>
-                        <a:rPr sz="1200" b="0">
+                        <a:rPr sz="1100" b="0">
                           <a:solidFill>
                             <a:srgbClr val="1A1A1A"/>
                           </a:solidFill>
@@ -21009,13 +21434,36 @@
                     <a:p>
                       <a:pPr algn="r"/>
                       <a:r>
-                        <a:rPr sz="1200" b="0">
+                        <a:rPr sz="1100" b="0">
                           <a:solidFill>
                             <a:srgbClr val="1A1A1A"/>
                           </a:solidFill>
                           <a:latin typeface="Calibri"/>
                         </a:rPr>
                         <a:t>EUR 3,801</a:t>
+                      </a:r>
+                    </a:p>
+                  </a:txBody>
+                  <a:tcPr anchor="ctr" marL="73152" marR="73152">
+                    <a:solidFill>
+                      <a:srgbClr val="ECECEC"/>
+                    </a:solidFill>
+                  </a:tcPr>
+                </a:tc>
+                <a:tc>
+                  <a:txBody>
+                    <a:bodyPr/>
+                    <a:lstStyle/>
+                    <a:p>
+                      <a:pPr algn="r"/>
+                      <a:r>
+                        <a:rPr sz="1100" b="0">
+                          <a:solidFill>
+                            <a:srgbClr val="1A1A1A"/>
+                          </a:solidFill>
+                          <a:latin typeface="Calibri"/>
+                        </a:rPr>
+                        <a:t>EUR 2,098</a:t>
                       </a:r>
                     </a:p>
                   </a:txBody>
@@ -21034,13 +21482,13 @@
                     <a:p>
                       <a:pPr algn="l"/>
                       <a:r>
-                        <a:rPr sz="1200" b="0">
+                        <a:rPr sz="1100" b="0">
                           <a:solidFill>
                             <a:srgbClr val="1A1A1A"/>
                           </a:solidFill>
                           <a:latin typeface="Calibri"/>
                         </a:rPr>
-                        <a:t>7552348290</a:t>
+                        <a:t>8975595830</a:t>
                       </a:r>
                     </a:p>
                   </a:txBody>
@@ -21057,13 +21505,36 @@
                     <a:p>
                       <a:pPr algn="l"/>
                       <a:r>
-                        <a:rPr sz="1200" b="0">
+                        <a:rPr sz="1100" b="0">
                           <a:solidFill>
                             <a:srgbClr val="1A1A1A"/>
                           </a:solidFill>
                           <a:latin typeface="Calibri"/>
                         </a:rPr>
-                        <a:t>STEERING UNIT</a:t>
+                        <a:t>PANEL; SIDE GATE</a:t>
+                      </a:r>
+                    </a:p>
+                  </a:txBody>
+                  <a:tcPr anchor="ctr" marL="73152" marR="73152">
+                    <a:solidFill>
+                      <a:srgbClr val="FFFFFF"/>
+                    </a:solidFill>
+                  </a:tcPr>
+                </a:tc>
+                <a:tc>
+                  <a:txBody>
+                    <a:bodyPr/>
+                    <a:lstStyle/>
+                    <a:p>
+                      <a:pPr algn="l"/>
+                      <a:r>
+                        <a:rPr sz="1100" b="0">
+                          <a:solidFill>
+                            <a:srgbClr val="1A1A1A"/>
+                          </a:solidFill>
+                          <a:latin typeface="Calibri"/>
+                        </a:rPr>
+                        <a:t>—</a:t>
                       </a:r>
                     </a:p>
                   </a:txBody>
@@ -21080,13 +21551,13 @@
                     <a:p>
                       <a:pPr algn="r"/>
                       <a:r>
-                        <a:rPr sz="1200" b="0">
+                        <a:rPr sz="1100" b="0">
                           <a:solidFill>
                             <a:srgbClr val="1A1A1A"/>
                           </a:solidFill>
                           <a:latin typeface="Calibri"/>
                         </a:rPr>
-                        <a:t>EUR 19,839</a:t>
+                        <a:t>EUR 430</a:t>
                       </a:r>
                     </a:p>
                   </a:txBody>
@@ -21103,13 +21574,36 @@
                     <a:p>
                       <a:pPr algn="r"/>
                       <a:r>
-                        <a:rPr sz="1200" b="0">
+                        <a:rPr sz="1100" b="0">
                           <a:solidFill>
                             <a:srgbClr val="1A1A1A"/>
                           </a:solidFill>
                           <a:latin typeface="Calibri"/>
                         </a:rPr>
-                        <a:t>EUR 21,823</a:t>
+                        <a:t>EUR 2,130</a:t>
+                      </a:r>
+                    </a:p>
+                  </a:txBody>
+                  <a:tcPr anchor="ctr" marL="73152" marR="73152">
+                    <a:solidFill>
+                      <a:srgbClr val="FFFFFF"/>
+                    </a:solidFill>
+                  </a:tcPr>
+                </a:tc>
+                <a:tc>
+                  <a:txBody>
+                    <a:bodyPr/>
+                    <a:lstStyle/>
+                    <a:p>
+                      <a:pPr algn="r"/>
+                      <a:r>
+                        <a:rPr sz="1100" b="0">
+                          <a:solidFill>
+                            <a:srgbClr val="1A1A1A"/>
+                          </a:solidFill>
+                          <a:latin typeface="Calibri"/>
+                        </a:rPr>
+                        <a:t>EUR 1,700</a:t>
                       </a:r>
                     </a:p>
                   </a:txBody>
@@ -21128,13 +21622,13 @@
                     <a:p>
                       <a:pPr algn="l"/>
                       <a:r>
-                        <a:rPr sz="1200" b="0">
+                        <a:rPr sz="1100" b="0">
                           <a:solidFill>
                             <a:srgbClr val="1A1A1A"/>
                           </a:solidFill>
                           <a:latin typeface="Calibri"/>
                         </a:rPr>
-                        <a:t>8975595830</a:t>
+                        <a:t>8983320160</a:t>
                       </a:r>
                     </a:p>
                   </a:txBody>
@@ -21151,13 +21645,36 @@
                     <a:p>
                       <a:pPr algn="l"/>
                       <a:r>
-                        <a:rPr sz="1200" b="0">
+                        <a:rPr sz="1100" b="0">
                           <a:solidFill>
                             <a:srgbClr val="1A1A1A"/>
                           </a:solidFill>
                           <a:latin typeface="Calibri"/>
                         </a:rPr>
-                        <a:t>PANEL; SIDE GATE</a:t>
+                        <a:t>VALVE; EGR</a:t>
+                      </a:r>
+                    </a:p>
+                  </a:txBody>
+                  <a:tcPr anchor="ctr" marL="73152" marR="73152">
+                    <a:solidFill>
+                      <a:srgbClr val="ECECEC"/>
+                    </a:solidFill>
+                  </a:tcPr>
+                </a:tc>
+                <a:tc>
+                  <a:txBody>
+                    <a:bodyPr/>
+                    <a:lstStyle/>
+                    <a:p>
+                      <a:pPr algn="l"/>
+                      <a:r>
+                        <a:rPr sz="1100" b="0">
+                          <a:solidFill>
+                            <a:srgbClr val="1A1A1A"/>
+                          </a:solidFill>
+                          <a:latin typeface="Calibri"/>
+                        </a:rPr>
+                        <a:t>—</a:t>
                       </a:r>
                     </a:p>
                   </a:txBody>
@@ -21174,13 +21691,13 @@
                     <a:p>
                       <a:pPr algn="r"/>
                       <a:r>
-                        <a:rPr sz="1200" b="0">
+                        <a:rPr sz="1100" b="0">
                           <a:solidFill>
                             <a:srgbClr val="1A1A1A"/>
                           </a:solidFill>
                           <a:latin typeface="Calibri"/>
                         </a:rPr>
-                        <a:t>EUR 430</a:t>
+                        <a:t>EUR 220</a:t>
                       </a:r>
                     </a:p>
                   </a:txBody>
@@ -21197,13 +21714,36 @@
                     <a:p>
                       <a:pPr algn="r"/>
                       <a:r>
-                        <a:rPr sz="1200" b="0">
+                        <a:rPr sz="1100" b="0">
                           <a:solidFill>
                             <a:srgbClr val="1A1A1A"/>
                           </a:solidFill>
                           <a:latin typeface="Calibri"/>
                         </a:rPr>
-                        <a:t>EUR 2,130</a:t>
+                        <a:t>EUR 1,397</a:t>
+                      </a:r>
+                    </a:p>
+                  </a:txBody>
+                  <a:tcPr anchor="ctr" marL="73152" marR="73152">
+                    <a:solidFill>
+                      <a:srgbClr val="ECECEC"/>
+                    </a:solidFill>
+                  </a:tcPr>
+                </a:tc>
+                <a:tc>
+                  <a:txBody>
+                    <a:bodyPr/>
+                    <a:lstStyle/>
+                    <a:p>
+                      <a:pPr algn="r"/>
+                      <a:r>
+                        <a:rPr sz="1100" b="0">
+                          <a:solidFill>
+                            <a:srgbClr val="1A1A1A"/>
+                          </a:solidFill>
+                          <a:latin typeface="Calibri"/>
+                        </a:rPr>
+                        <a:t>EUR 1,178</a:t>
                       </a:r>
                     </a:p>
                   </a:txBody>
@@ -21222,13 +21762,13 @@
                     <a:p>
                       <a:pPr algn="l"/>
                       <a:r>
-                        <a:rPr sz="1200" b="0">
+                        <a:rPr sz="1100" b="0">
                           <a:solidFill>
                             <a:srgbClr val="1A1A1A"/>
                           </a:solidFill>
                           <a:latin typeface="Calibri"/>
                         </a:rPr>
-                        <a:t>8983320160</a:t>
+                        <a:t>8978249035</a:t>
                       </a:r>
                     </a:p>
                   </a:txBody>
@@ -21245,13 +21785,36 @@
                     <a:p>
                       <a:pPr algn="l"/>
                       <a:r>
-                        <a:rPr sz="1200" b="0">
+                        <a:rPr sz="1100" b="0">
                           <a:solidFill>
                             <a:srgbClr val="1A1A1A"/>
                           </a:solidFill>
                           <a:latin typeface="Calibri"/>
                         </a:rPr>
-                        <a:t>VALVE; EGR</a:t>
+                        <a:t>LAMP ASM; HEAD</a:t>
+                      </a:r>
+                    </a:p>
+                  </a:txBody>
+                  <a:tcPr anchor="ctr" marL="73152" marR="73152">
+                    <a:solidFill>
+                      <a:srgbClr val="FFFFFF"/>
+                    </a:solidFill>
+                  </a:tcPr>
+                </a:tc>
+                <a:tc>
+                  <a:txBody>
+                    <a:bodyPr/>
+                    <a:lstStyle/>
+                    <a:p>
+                      <a:pPr algn="l"/>
+                      <a:r>
+                        <a:rPr sz="1100" b="0">
+                          <a:solidFill>
+                            <a:srgbClr val="1A1A1A"/>
+                          </a:solidFill>
+                          <a:latin typeface="Calibri"/>
+                        </a:rPr>
+                        <a:t>—</a:t>
                       </a:r>
                     </a:p>
                   </a:txBody>
@@ -21268,13 +21831,13 @@
                     <a:p>
                       <a:pPr algn="r"/>
                       <a:r>
-                        <a:rPr sz="1200" b="0">
+                        <a:rPr sz="1100" b="0">
                           <a:solidFill>
                             <a:srgbClr val="1A1A1A"/>
                           </a:solidFill>
                           <a:latin typeface="Calibri"/>
                         </a:rPr>
-                        <a:t>EUR 220</a:t>
+                        <a:t>EUR 338</a:t>
                       </a:r>
                     </a:p>
                   </a:txBody>
@@ -21291,13 +21854,36 @@
                     <a:p>
                       <a:pPr algn="r"/>
                       <a:r>
-                        <a:rPr sz="1200" b="0">
+                        <a:rPr sz="1100" b="0">
                           <a:solidFill>
                             <a:srgbClr val="1A1A1A"/>
                           </a:solidFill>
                           <a:latin typeface="Calibri"/>
                         </a:rPr>
-                        <a:t>EUR 1,397</a:t>
+                        <a:t>EUR 1,313</a:t>
+                      </a:r>
+                    </a:p>
+                  </a:txBody>
+                  <a:tcPr anchor="ctr" marL="73152" marR="73152">
+                    <a:solidFill>
+                      <a:srgbClr val="FFFFFF"/>
+                    </a:solidFill>
+                  </a:tcPr>
+                </a:tc>
+                <a:tc>
+                  <a:txBody>
+                    <a:bodyPr/>
+                    <a:lstStyle/>
+                    <a:p>
+                      <a:pPr algn="r"/>
+                      <a:r>
+                        <a:rPr sz="1100" b="0">
+                          <a:solidFill>
+                            <a:srgbClr val="1A1A1A"/>
+                          </a:solidFill>
+                          <a:latin typeface="Calibri"/>
+                        </a:rPr>
+                        <a:t>EUR 975</a:t>
                       </a:r>
                     </a:p>
                   </a:txBody>
@@ -21316,13 +21902,13 @@
                     <a:p>
                       <a:pPr algn="l"/>
                       <a:r>
-                        <a:rPr sz="1200" b="0">
+                        <a:rPr sz="1100" b="0">
                           <a:solidFill>
                             <a:srgbClr val="1A1A1A"/>
                           </a:solidFill>
                           <a:latin typeface="Calibri"/>
                         </a:rPr>
-                        <a:t>8978249035</a:t>
+                        <a:t>5876150530</a:t>
                       </a:r>
                     </a:p>
                   </a:txBody>
@@ -21339,13 +21925,36 @@
                     <a:p>
                       <a:pPr algn="l"/>
                       <a:r>
-                        <a:rPr sz="1200" b="0">
+                        <a:rPr sz="1100" b="0">
                           <a:solidFill>
                             <a:srgbClr val="1A1A1A"/>
                           </a:solidFill>
                           <a:latin typeface="Calibri"/>
                         </a:rPr>
-                        <a:t>LAMP ASM; HEAD</a:t>
+                        <a:t>ELEMENT; OIL FILTER</a:t>
+                      </a:r>
+                    </a:p>
+                  </a:txBody>
+                  <a:tcPr anchor="ctr" marL="73152" marR="73152">
+                    <a:solidFill>
+                      <a:srgbClr val="ECECEC"/>
+                    </a:solidFill>
+                  </a:tcPr>
+                </a:tc>
+                <a:tc>
+                  <a:txBody>
+                    <a:bodyPr/>
+                    <a:lstStyle/>
+                    <a:p>
+                      <a:pPr algn="l"/>
+                      <a:r>
+                        <a:rPr sz="1100" b="0">
+                          <a:solidFill>
+                            <a:srgbClr val="1A1A1A"/>
+                          </a:solidFill>
+                          <a:latin typeface="Calibri"/>
+                        </a:rPr>
+                        <a:t>NHR,NLR,NMR,TF*,</a:t>
                       </a:r>
                     </a:p>
                   </a:txBody>
@@ -21362,13 +21971,13 @@
                     <a:p>
                       <a:pPr algn="r"/>
                       <a:r>
-                        <a:rPr sz="1200" b="0">
+                        <a:rPr sz="1100" b="0">
                           <a:solidFill>
                             <a:srgbClr val="1A1A1A"/>
                           </a:solidFill>
                           <a:latin typeface="Calibri"/>
                         </a:rPr>
-                        <a:t>EUR 338</a:t>
+                        <a:t>EUR 51</a:t>
                       </a:r>
                     </a:p>
                   </a:txBody>
@@ -21385,13 +21994,36 @@
                     <a:p>
                       <a:pPr algn="r"/>
                       <a:r>
-                        <a:rPr sz="1200" b="0">
+                        <a:rPr sz="1100" b="0">
                           <a:solidFill>
                             <a:srgbClr val="1A1A1A"/>
                           </a:solidFill>
                           <a:latin typeface="Calibri"/>
                         </a:rPr>
-                        <a:t>EUR 1,313</a:t>
+                        <a:t>EUR 857</a:t>
+                      </a:r>
+                    </a:p>
+                  </a:txBody>
+                  <a:tcPr anchor="ctr" marL="73152" marR="73152">
+                    <a:solidFill>
+                      <a:srgbClr val="ECECEC"/>
+                    </a:solidFill>
+                  </a:tcPr>
+                </a:tc>
+                <a:tc>
+                  <a:txBody>
+                    <a:bodyPr/>
+                    <a:lstStyle/>
+                    <a:p>
+                      <a:pPr algn="r"/>
+                      <a:r>
+                        <a:rPr sz="1100" b="0">
+                          <a:solidFill>
+                            <a:srgbClr val="1A1A1A"/>
+                          </a:solidFill>
+                          <a:latin typeface="Calibri"/>
+                        </a:rPr>
+                        <a:t>EUR 806</a:t>
                       </a:r>
                     </a:p>
                   </a:txBody>
@@ -21452,7 +22084,7 @@
                 </a:solidFill>
                 <a:latin typeface="Calibri"/>
               </a:rPr>
-              <a:t>Air conditioning +39%, Electrical sensors +20%, Body parts +9% — where the volume went.</a:t>
+              <a:t>Air conditioning +37%, Body parts +12%, Fuel system +553% — where the commercial volume went.</a:t>
             </a:r>
           </a:p>
           <a:p>
@@ -21480,7 +22112,7 @@
                 </a:solidFill>
                 <a:latin typeface="Calibri"/>
               </a:rPr>
-              <a:t>Several of these are the kind of item that also moves on a campaign or claim. Hungary CY2025 warranty parts (claim-price basis) were EUR 77K — separate from fiscal GPS warranty expense. Do not read this growth list as purely commercial without checking claims together.</a:t>
+              <a:t>Claim-matched PNs (87 distinct) and campaign/recall text matches are already excluded from this growth list. Residual warranty on unmapped PNs can remain.</a:t>
             </a:r>
           </a:p>
           <a:p>
@@ -21508,7 +22140,7 @@
                 </a:solidFill>
                 <a:latin typeface="Calibri"/>
               </a:rPr>
-              <a:t>Worth agreeing which of these are repeatable and which were one-off.</a:t>
+              <a:t>PNs ranked by largest EUR increase (prior-period sales &gt; 0). Worth agreeing which of these are repeatable and which were one-off.</a:t>
             </a:r>
           </a:p>
         </p:txBody>
@@ -22049,7 +22681,7 @@
                           </a:solidFill>
                           <a:latin typeface="Calibri"/>
                         </a:rPr>
-                        <a:t>Validate</a:t>
+                        <a:t>Warranty / campaign</a:t>
                       </a:r>
                     </a:p>
                   </a:txBody>

</xml_diff>